<commit_message>
Curso 2026 | 2027 - Nuevas órbitas.
</commit_message>
<xml_diff>
--- a/docs/orbitas/orbita1/slides/pptx/orbita1_00_hoja_de_ruta.pptx
+++ b/docs/orbitas/orbita1/slides/pptx/orbita1_00_hoja_de_ruta.pptx
@@ -1302,7 +1302,7 @@
     <p:bg>
       <p:bgPr>
         <a:solidFill>
-          <a:srgbClr val="1A1A1A"/>
+          <a:srgbClr val="240509"/>
         </a:solidFill>
       </p:bgPr>
     </p:bg>
@@ -1367,7 +1367,7 @@
             <a:r>
               <a:rPr lang="en-US" sz="1400" b="1" dirty="0">
                 <a:solidFill>
-                  <a:srgbClr val="1A1A1A"/>
+                  <a:srgbClr val="240509"/>
                 </a:solidFill>
                 <a:latin typeface="Arial" pitchFamily="34" charset="0"/>
                 <a:ea typeface="Arial" pitchFamily="34" charset="-122"/>
@@ -1406,7 +1406,7 @@
             <a:r>
               <a:rPr lang="en-US" sz="4000" b="1" dirty="0">
                 <a:solidFill>
-                  <a:srgbClr val="FFFFFF"/>
+                  <a:srgbClr val="FBFBF8"/>
                 </a:solidFill>
                 <a:latin typeface="Arial" pitchFamily="34" charset="0"/>
                 <a:ea typeface="Arial" pitchFamily="34" charset="-122"/>
@@ -1445,7 +1445,7 @@
             <a:r>
               <a:rPr lang="en-US" sz="1800" dirty="0">
                 <a:solidFill>
-                  <a:srgbClr val="FFE156"/>
+                  <a:srgbClr val="F7D597"/>
                 </a:solidFill>
                 <a:latin typeface="Arial" pitchFamily="34" charset="0"/>
                 <a:ea typeface="Arial" pitchFamily="34" charset="-122"/>
@@ -1510,7 +1510,7 @@
     <p:bg>
       <p:bgPr>
         <a:solidFill>
-          <a:srgbClr val="FFFFFF"/>
+          <a:srgbClr val="FBFBF8"/>
         </a:solidFill>
       </p:bgPr>
     </p:bg>
@@ -1555,7 +1555,7 @@
             <a:r>
               <a:rPr lang="en-US" sz="2600" b="1" dirty="0">
                 <a:solidFill>
-                  <a:srgbClr val="1A1A1A"/>
+                  <a:srgbClr val="240509"/>
                 </a:solidFill>
                 <a:latin typeface="Arial" pitchFamily="34" charset="0"/>
                 <a:ea typeface="Arial" pitchFamily="34" charset="-122"/>
@@ -1614,7 +1614,7 @@
             <a:r>
               <a:rPr lang="en-US" sz="1800" b="1" dirty="0">
                 <a:solidFill>
-                  <a:srgbClr val="FFFFFF"/>
+                  <a:srgbClr val="FBFBF8"/>
                 </a:solidFill>
                 <a:latin typeface="Arial" pitchFamily="34" charset="0"/>
                 <a:ea typeface="Arial" pitchFamily="34" charset="-122"/>
@@ -1653,7 +1653,7 @@
             <a:r>
               <a:rPr lang="en-US" sz="1600" b="1" dirty="0">
                 <a:solidFill>
-                  <a:srgbClr val="1A1A1A"/>
+                  <a:srgbClr val="240509"/>
                 </a:solidFill>
                 <a:latin typeface="Arial" pitchFamily="34" charset="0"/>
                 <a:ea typeface="Arial" pitchFamily="34" charset="-122"/>
@@ -1692,7 +1692,7 @@
             <a:r>
               <a:rPr lang="en-US" sz="1300" dirty="0">
                 <a:solidFill>
-                  <a:srgbClr val="333333"/>
+                  <a:srgbClr val="4A5568"/>
                 </a:solidFill>
                 <a:latin typeface="Arial" pitchFamily="34" charset="0"/>
                 <a:ea typeface="Arial" pitchFamily="34" charset="-122"/>
@@ -1751,7 +1751,7 @@
             <a:r>
               <a:rPr lang="en-US" sz="1800" b="1" dirty="0">
                 <a:solidFill>
-                  <a:srgbClr val="FFFFFF"/>
+                  <a:srgbClr val="FBFBF8"/>
                 </a:solidFill>
                 <a:latin typeface="Arial" pitchFamily="34" charset="0"/>
                 <a:ea typeface="Arial" pitchFamily="34" charset="-122"/>
@@ -1790,7 +1790,7 @@
             <a:r>
               <a:rPr lang="en-US" sz="1600" b="1" dirty="0">
                 <a:solidFill>
-                  <a:srgbClr val="1A1A1A"/>
+                  <a:srgbClr val="240509"/>
                 </a:solidFill>
                 <a:latin typeface="Arial" pitchFamily="34" charset="0"/>
                 <a:ea typeface="Arial" pitchFamily="34" charset="-122"/>
@@ -1829,7 +1829,7 @@
             <a:r>
               <a:rPr lang="en-US" sz="1300" dirty="0">
                 <a:solidFill>
-                  <a:srgbClr val="333333"/>
+                  <a:srgbClr val="4A5568"/>
                 </a:solidFill>
                 <a:latin typeface="Arial" pitchFamily="34" charset="0"/>
                 <a:ea typeface="Arial" pitchFamily="34" charset="-122"/>
@@ -1888,7 +1888,7 @@
             <a:r>
               <a:rPr lang="en-US" sz="1800" b="1" dirty="0">
                 <a:solidFill>
-                  <a:srgbClr val="FFFFFF"/>
+                  <a:srgbClr val="FBFBF8"/>
                 </a:solidFill>
                 <a:latin typeface="Arial" pitchFamily="34" charset="0"/>
                 <a:ea typeface="Arial" pitchFamily="34" charset="-122"/>
@@ -1927,7 +1927,7 @@
             <a:r>
               <a:rPr lang="en-US" sz="1600" b="1" dirty="0">
                 <a:solidFill>
-                  <a:srgbClr val="1A1A1A"/>
+                  <a:srgbClr val="240509"/>
                 </a:solidFill>
                 <a:latin typeface="Arial" pitchFamily="34" charset="0"/>
                 <a:ea typeface="Arial" pitchFamily="34" charset="-122"/>
@@ -1966,7 +1966,7 @@
             <a:r>
               <a:rPr lang="en-US" sz="1300" dirty="0">
                 <a:solidFill>
-                  <a:srgbClr val="333333"/>
+                  <a:srgbClr val="4A5568"/>
                 </a:solidFill>
                 <a:latin typeface="Arial" pitchFamily="34" charset="0"/>
                 <a:ea typeface="Arial" pitchFamily="34" charset="-122"/>
@@ -1992,7 +1992,7 @@
     <p:bg>
       <p:bgPr>
         <a:solidFill>
-          <a:srgbClr val="FFFFFF"/>
+          <a:srgbClr val="FBFBF8"/>
         </a:solidFill>
       </p:bgPr>
     </p:bg>
@@ -2037,7 +2037,7 @@
             <a:r>
               <a:rPr lang="en-US" sz="2600" b="1" dirty="0">
                 <a:solidFill>
-                  <a:srgbClr val="1A1A1A"/>
+                  <a:srgbClr val="240509"/>
                 </a:solidFill>
                 <a:latin typeface="Arial" pitchFamily="34" charset="0"/>
                 <a:ea typeface="Arial" pitchFamily="34" charset="-122"/>
@@ -2096,7 +2096,7 @@
             <a:r>
               <a:rPr lang="en-US" sz="1800" b="1" dirty="0">
                 <a:solidFill>
-                  <a:srgbClr val="FFFFFF"/>
+                  <a:srgbClr val="FBFBF8"/>
                 </a:solidFill>
                 <a:latin typeface="Arial" pitchFamily="34" charset="0"/>
                 <a:ea typeface="Arial" pitchFamily="34" charset="-122"/>
@@ -2135,7 +2135,7 @@
             <a:r>
               <a:rPr lang="en-US" sz="1600" b="1" dirty="0">
                 <a:solidFill>
-                  <a:srgbClr val="1A1A1A"/>
+                  <a:srgbClr val="240509"/>
                 </a:solidFill>
                 <a:latin typeface="Arial" pitchFamily="34" charset="0"/>
                 <a:ea typeface="Arial" pitchFamily="34" charset="-122"/>
@@ -2174,7 +2174,7 @@
             <a:r>
               <a:rPr lang="en-US" sz="1300" dirty="0">
                 <a:solidFill>
-                  <a:srgbClr val="333333"/>
+                  <a:srgbClr val="4A5568"/>
                 </a:solidFill>
                 <a:latin typeface="Arial" pitchFamily="34" charset="0"/>
                 <a:ea typeface="Arial" pitchFamily="34" charset="-122"/>
@@ -2233,7 +2233,7 @@
             <a:r>
               <a:rPr lang="en-US" sz="1800" b="1" dirty="0">
                 <a:solidFill>
-                  <a:srgbClr val="FFFFFF"/>
+                  <a:srgbClr val="FBFBF8"/>
                 </a:solidFill>
                 <a:latin typeface="Arial" pitchFamily="34" charset="0"/>
                 <a:ea typeface="Arial" pitchFamily="34" charset="-122"/>
@@ -2272,7 +2272,7 @@
             <a:r>
               <a:rPr lang="en-US" sz="1600" b="1" dirty="0">
                 <a:solidFill>
-                  <a:srgbClr val="1A1A1A"/>
+                  <a:srgbClr val="240509"/>
                 </a:solidFill>
                 <a:latin typeface="Arial" pitchFamily="34" charset="0"/>
                 <a:ea typeface="Arial" pitchFamily="34" charset="-122"/>
@@ -2311,7 +2311,7 @@
             <a:r>
               <a:rPr lang="en-US" sz="1300" dirty="0">
                 <a:solidFill>
-                  <a:srgbClr val="333333"/>
+                  <a:srgbClr val="4A5568"/>
                 </a:solidFill>
                 <a:latin typeface="Arial" pitchFamily="34" charset="0"/>
                 <a:ea typeface="Arial" pitchFamily="34" charset="-122"/>
@@ -2370,7 +2370,7 @@
             <a:r>
               <a:rPr lang="en-US" sz="1800" b="1" dirty="0">
                 <a:solidFill>
-                  <a:srgbClr val="FFFFFF"/>
+                  <a:srgbClr val="FBFBF8"/>
                 </a:solidFill>
                 <a:latin typeface="Arial" pitchFamily="34" charset="0"/>
                 <a:ea typeface="Arial" pitchFamily="34" charset="-122"/>
@@ -2409,7 +2409,7 @@
             <a:r>
               <a:rPr lang="en-US" sz="1600" b="1" dirty="0">
                 <a:solidFill>
-                  <a:srgbClr val="1A1A1A"/>
+                  <a:srgbClr val="240509"/>
                 </a:solidFill>
                 <a:latin typeface="Arial" pitchFamily="34" charset="0"/>
                 <a:ea typeface="Arial" pitchFamily="34" charset="-122"/>
@@ -2448,7 +2448,7 @@
             <a:r>
               <a:rPr lang="en-US" sz="1300" dirty="0">
                 <a:solidFill>
-                  <a:srgbClr val="333333"/>
+                  <a:srgbClr val="4A5568"/>
                 </a:solidFill>
                 <a:latin typeface="Arial" pitchFamily="34" charset="0"/>
                 <a:ea typeface="Arial" pitchFamily="34" charset="-122"/>
@@ -2474,7 +2474,7 @@
     <p:bg>
       <p:bgPr>
         <a:solidFill>
-          <a:srgbClr val="FFFFFF"/>
+          <a:srgbClr val="FBFBF8"/>
         </a:solidFill>
       </p:bgPr>
     </p:bg>
@@ -2519,7 +2519,7 @@
             <a:r>
               <a:rPr lang="en-US" sz="2600" b="1" dirty="0">
                 <a:solidFill>
-                  <a:srgbClr val="1A1A1A"/>
+                  <a:srgbClr val="240509"/>
                 </a:solidFill>
                 <a:latin typeface="Arial" pitchFamily="34" charset="0"/>
                 <a:ea typeface="Arial" pitchFamily="34" charset="-122"/>
@@ -2578,7 +2578,7 @@
             <a:r>
               <a:rPr lang="en-US" sz="1800" b="1" dirty="0">
                 <a:solidFill>
-                  <a:srgbClr val="FFFFFF"/>
+                  <a:srgbClr val="FBFBF8"/>
                 </a:solidFill>
                 <a:latin typeface="Arial" pitchFamily="34" charset="0"/>
                 <a:ea typeface="Arial" pitchFamily="34" charset="-122"/>
@@ -2617,7 +2617,7 @@
             <a:r>
               <a:rPr lang="en-US" sz="1600" b="1" dirty="0">
                 <a:solidFill>
-                  <a:srgbClr val="1A1A1A"/>
+                  <a:srgbClr val="240509"/>
                 </a:solidFill>
                 <a:latin typeface="Arial" pitchFamily="34" charset="0"/>
                 <a:ea typeface="Arial" pitchFamily="34" charset="-122"/>
@@ -2656,7 +2656,7 @@
             <a:r>
               <a:rPr lang="en-US" sz="1300" dirty="0">
                 <a:solidFill>
-                  <a:srgbClr val="333333"/>
+                  <a:srgbClr val="4A5568"/>
                 </a:solidFill>
                 <a:latin typeface="Arial" pitchFamily="34" charset="0"/>
                 <a:ea typeface="Arial" pitchFamily="34" charset="-122"/>
@@ -2715,7 +2715,7 @@
             <a:r>
               <a:rPr lang="en-US" sz="1800" b="1" dirty="0">
                 <a:solidFill>
-                  <a:srgbClr val="FFFFFF"/>
+                  <a:srgbClr val="FBFBF8"/>
                 </a:solidFill>
                 <a:latin typeface="Arial" pitchFamily="34" charset="0"/>
                 <a:ea typeface="Arial" pitchFamily="34" charset="-122"/>
@@ -2754,7 +2754,7 @@
             <a:r>
               <a:rPr lang="en-US" sz="1600" b="1" dirty="0">
                 <a:solidFill>
-                  <a:srgbClr val="1A1A1A"/>
+                  <a:srgbClr val="240509"/>
                 </a:solidFill>
                 <a:latin typeface="Arial" pitchFamily="34" charset="0"/>
                 <a:ea typeface="Arial" pitchFamily="34" charset="-122"/>
@@ -2793,7 +2793,7 @@
             <a:r>
               <a:rPr lang="en-US" sz="1300" dirty="0">
                 <a:solidFill>
-                  <a:srgbClr val="333333"/>
+                  <a:srgbClr val="4A5568"/>
                 </a:solidFill>
                 <a:latin typeface="Arial" pitchFamily="34" charset="0"/>
                 <a:ea typeface="Arial" pitchFamily="34" charset="-122"/>
@@ -2852,7 +2852,7 @@
             <a:r>
               <a:rPr lang="en-US" sz="1800" b="1" dirty="0">
                 <a:solidFill>
-                  <a:srgbClr val="FFFFFF"/>
+                  <a:srgbClr val="FBFBF8"/>
                 </a:solidFill>
                 <a:latin typeface="Arial" pitchFamily="34" charset="0"/>
                 <a:ea typeface="Arial" pitchFamily="34" charset="-122"/>
@@ -2891,7 +2891,7 @@
             <a:r>
               <a:rPr lang="en-US" sz="1600" b="1" dirty="0">
                 <a:solidFill>
-                  <a:srgbClr val="1A1A1A"/>
+                  <a:srgbClr val="240509"/>
                 </a:solidFill>
                 <a:latin typeface="Arial" pitchFamily="34" charset="0"/>
                 <a:ea typeface="Arial" pitchFamily="34" charset="-122"/>
@@ -2930,7 +2930,7 @@
             <a:r>
               <a:rPr lang="en-US" sz="1300" dirty="0">
                 <a:solidFill>
-                  <a:srgbClr val="333333"/>
+                  <a:srgbClr val="4A5568"/>
                 </a:solidFill>
                 <a:latin typeface="Arial" pitchFamily="34" charset="0"/>
                 <a:ea typeface="Arial" pitchFamily="34" charset="-122"/>
@@ -2989,7 +2989,7 @@
             <a:r>
               <a:rPr lang="en-US" sz="1800" b="1" dirty="0">
                 <a:solidFill>
-                  <a:srgbClr val="FFFFFF"/>
+                  <a:srgbClr val="FBFBF8"/>
                 </a:solidFill>
                 <a:latin typeface="Arial" pitchFamily="34" charset="0"/>
                 <a:ea typeface="Arial" pitchFamily="34" charset="-122"/>
@@ -3028,7 +3028,7 @@
             <a:r>
               <a:rPr lang="en-US" sz="1600" b="1" dirty="0">
                 <a:solidFill>
-                  <a:srgbClr val="1A1A1A"/>
+                  <a:srgbClr val="240509"/>
                 </a:solidFill>
                 <a:latin typeface="Arial" pitchFamily="34" charset="0"/>
                 <a:ea typeface="Arial" pitchFamily="34" charset="-122"/>
@@ -3067,7 +3067,7 @@
             <a:r>
               <a:rPr lang="en-US" sz="1300" dirty="0">
                 <a:solidFill>
-                  <a:srgbClr val="333333"/>
+                  <a:srgbClr val="4A5568"/>
                 </a:solidFill>
                 <a:latin typeface="Arial" pitchFamily="34" charset="0"/>
                 <a:ea typeface="Arial" pitchFamily="34" charset="-122"/>
@@ -3093,7 +3093,7 @@
     <p:bg>
       <p:bgPr>
         <a:solidFill>
-          <a:srgbClr val="FFFFFF"/>
+          <a:srgbClr val="FBFBF8"/>
         </a:solidFill>
       </p:bgPr>
     </p:bg>
@@ -3138,7 +3138,7 @@
             <a:r>
               <a:rPr lang="en-US" sz="2600" b="1" dirty="0">
                 <a:solidFill>
-                  <a:srgbClr val="1A1A1A"/>
+                  <a:srgbClr val="240509"/>
                 </a:solidFill>
                 <a:latin typeface="Arial" pitchFamily="34" charset="0"/>
                 <a:ea typeface="Arial" pitchFamily="34" charset="-122"/>
@@ -3197,7 +3197,7 @@
             <a:r>
               <a:rPr lang="en-US" sz="1800" b="1" dirty="0">
                 <a:solidFill>
-                  <a:srgbClr val="FFFFFF"/>
+                  <a:srgbClr val="FBFBF8"/>
                 </a:solidFill>
                 <a:latin typeface="Arial" pitchFamily="34" charset="0"/>
                 <a:ea typeface="Arial" pitchFamily="34" charset="-122"/>
@@ -3236,7 +3236,7 @@
             <a:r>
               <a:rPr lang="en-US" sz="1600" b="1" dirty="0">
                 <a:solidFill>
-                  <a:srgbClr val="1A1A1A"/>
+                  <a:srgbClr val="240509"/>
                 </a:solidFill>
                 <a:latin typeface="Arial" pitchFamily="34" charset="0"/>
                 <a:ea typeface="Arial" pitchFamily="34" charset="-122"/>
@@ -3275,7 +3275,7 @@
             <a:r>
               <a:rPr lang="en-US" sz="1300" dirty="0">
                 <a:solidFill>
-                  <a:srgbClr val="333333"/>
+                  <a:srgbClr val="4A5568"/>
                 </a:solidFill>
                 <a:latin typeface="Arial" pitchFamily="34" charset="0"/>
                 <a:ea typeface="Arial" pitchFamily="34" charset="-122"/>
@@ -3334,7 +3334,7 @@
             <a:r>
               <a:rPr lang="en-US" sz="1800" b="1" dirty="0">
                 <a:solidFill>
-                  <a:srgbClr val="FFFFFF"/>
+                  <a:srgbClr val="FBFBF8"/>
                 </a:solidFill>
                 <a:latin typeface="Arial" pitchFamily="34" charset="0"/>
                 <a:ea typeface="Arial" pitchFamily="34" charset="-122"/>
@@ -3373,7 +3373,7 @@
             <a:r>
               <a:rPr lang="en-US" sz="1600" b="1" dirty="0">
                 <a:solidFill>
-                  <a:srgbClr val="1A1A1A"/>
+                  <a:srgbClr val="240509"/>
                 </a:solidFill>
                 <a:latin typeface="Arial" pitchFamily="34" charset="0"/>
                 <a:ea typeface="Arial" pitchFamily="34" charset="-122"/>
@@ -3412,7 +3412,7 @@
             <a:r>
               <a:rPr lang="en-US" sz="1300" dirty="0">
                 <a:solidFill>
-                  <a:srgbClr val="333333"/>
+                  <a:srgbClr val="4A5568"/>
                 </a:solidFill>
                 <a:latin typeface="Arial" pitchFamily="34" charset="0"/>
                 <a:ea typeface="Arial" pitchFamily="34" charset="-122"/>
@@ -3471,7 +3471,7 @@
             <a:r>
               <a:rPr lang="en-US" sz="1800" b="1" dirty="0">
                 <a:solidFill>
-                  <a:srgbClr val="FFFFFF"/>
+                  <a:srgbClr val="FBFBF8"/>
                 </a:solidFill>
                 <a:latin typeface="Arial" pitchFamily="34" charset="0"/>
                 <a:ea typeface="Arial" pitchFamily="34" charset="-122"/>
@@ -3510,7 +3510,7 @@
             <a:r>
               <a:rPr lang="en-US" sz="1600" b="1" dirty="0">
                 <a:solidFill>
-                  <a:srgbClr val="1A1A1A"/>
+                  <a:srgbClr val="240509"/>
                 </a:solidFill>
                 <a:latin typeface="Arial" pitchFamily="34" charset="0"/>
                 <a:ea typeface="Arial" pitchFamily="34" charset="-122"/>
@@ -3549,7 +3549,7 @@
             <a:r>
               <a:rPr lang="en-US" sz="1300" dirty="0">
                 <a:solidFill>
-                  <a:srgbClr val="333333"/>
+                  <a:srgbClr val="4A5568"/>
                 </a:solidFill>
                 <a:latin typeface="Arial" pitchFamily="34" charset="0"/>
                 <a:ea typeface="Arial" pitchFamily="34" charset="-122"/>
@@ -3608,7 +3608,7 @@
             <a:r>
               <a:rPr lang="en-US" sz="1800" b="1" dirty="0">
                 <a:solidFill>
-                  <a:srgbClr val="FFFFFF"/>
+                  <a:srgbClr val="FBFBF8"/>
                 </a:solidFill>
                 <a:latin typeface="Arial" pitchFamily="34" charset="0"/>
                 <a:ea typeface="Arial" pitchFamily="34" charset="-122"/>
@@ -3647,7 +3647,7 @@
             <a:r>
               <a:rPr lang="en-US" sz="1600" b="1" dirty="0">
                 <a:solidFill>
-                  <a:srgbClr val="1A1A1A"/>
+                  <a:srgbClr val="240509"/>
                 </a:solidFill>
                 <a:latin typeface="Arial" pitchFamily="34" charset="0"/>
                 <a:ea typeface="Arial" pitchFamily="34" charset="-122"/>
@@ -3686,7 +3686,7 @@
             <a:r>
               <a:rPr lang="en-US" sz="1300" dirty="0">
                 <a:solidFill>
-                  <a:srgbClr val="333333"/>
+                  <a:srgbClr val="4A5568"/>
                 </a:solidFill>
                 <a:latin typeface="Arial" pitchFamily="34" charset="0"/>
                 <a:ea typeface="Arial" pitchFamily="34" charset="-122"/>
@@ -3757,7 +3757,7 @@
             <a:r>
               <a:rPr lang="en-US" sz="1600" b="1" dirty="0">
                 <a:solidFill>
-                  <a:srgbClr val="1A1A1A"/>
+                  <a:srgbClr val="240509"/>
                 </a:solidFill>
                 <a:latin typeface="Arial" pitchFamily="34" charset="0"/>
                 <a:ea typeface="Arial" pitchFamily="34" charset="-122"/>
@@ -3796,7 +3796,7 @@
             <a:r>
               <a:rPr lang="en-US" sz="2400" b="1" dirty="0">
                 <a:solidFill>
-                  <a:srgbClr val="FFFFFF"/>
+                  <a:srgbClr val="FBFBF8"/>
                 </a:solidFill>
                 <a:latin typeface="Arial" pitchFamily="34" charset="0"/>
                 <a:ea typeface="Arial" pitchFamily="34" charset="-122"/>

</xml_diff>